<commit_message>
Add GitHub link and QR code to midterm deck
Co-authored-by: Munira <munira@knu.ac.kr>
</commit_message>
<xml_diff>
--- a/docs/midterm/v4/ADVS_1차중간발표.pptx
+++ b/docs/midterm/v4/ADVS_1차중간발표.pptx
@@ -6642,6 +6642,49 @@
           </a:p>
         </p:txBody>
       </p:sp>
+      <p:sp>
+        <p:nvSpPr>
+          <p:cNvPr id="8" name="TextBox 7">
+            <a:hlinkClick r:id="rId2"/>
+          </p:cNvPr>
+          <p:cNvSpPr txBox="1"/>
+          <p:nvPr/>
+        </p:nvSpPr>
+        <p:spPr>
+          <a:xfrm>
+            <a:off x="822960" y="5989320"/>
+            <a:ext cx="10515600" cy="411480"/>
+          </a:xfrm>
+          <a:prstGeom prst="rect">
+            <a:avLst/>
+          </a:prstGeom>
+          <a:noFill/>
+        </p:spPr>
+        <p:txBody>
+          <a:bodyPr wrap="square" anchor="t" lIns="0" rIns="0" tIns="0" bIns="0">
+            <a:spAutoFit/>
+          </a:bodyPr>
+          <a:lstStyle/>
+          <a:p>
+            <a:pPr algn="l">
+              <a:lnSpc>
+                <a:spcPct val="105000"/>
+              </a:lnSpc>
+            </a:pPr>
+            <a:r>
+              <a:rPr sz="1600" b="0" u="sng">
+                <a:solidFill>
+                  <a:srgbClr val="FFFFFF"/>
+                </a:solidFill>
+                <a:latin typeface="Helvetica Neue"/>
+                <a:cs typeface="Apple SD Gothic Neo"/>
+                <a:ea typeface="Apple SD Gothic Neo"/>
+              </a:rPr>
+              <a:t>GitHub: github.com/khabibro/ADVS</a:t>
+            </a:r>
+          </a:p>
+        </p:txBody>
+      </p:sp>
     </p:spTree>
   </p:cSld>
   <p:clrMapOvr>
@@ -17676,8 +17719,8 @@
         </p:nvSpPr>
         <p:spPr>
           <a:xfrm>
-            <a:off x="822960" y="5120640"/>
-            <a:ext cx="10515600" cy="457200"/>
+            <a:off x="822960" y="5394960"/>
+            <a:ext cx="7315200" cy="457200"/>
           </a:xfrm>
           <a:prstGeom prst="rect">
             <a:avLst/>
@@ -17711,7 +17754,118 @@
       </p:sp>
       <p:sp>
         <p:nvSpPr>
-          <p:cNvPr id="9" name="TextBox 8"/>
+          <p:cNvPr id="9" name="Rectangle 8"/>
+          <p:cNvSpPr/>
+          <p:nvPr/>
+        </p:nvSpPr>
+        <p:spPr>
+          <a:xfrm>
+            <a:off x="8732520" y="1737360"/>
+            <a:ext cx="3017520" cy="3017520"/>
+          </a:xfrm>
+          <a:prstGeom prst="rect">
+            <a:avLst/>
+          </a:prstGeom>
+          <a:solidFill>
+            <a:srgbClr val="FFFFFF"/>
+          </a:solidFill>
+          <a:ln>
+            <a:noFill/>
+          </a:ln>
+          <a:effectLst/>
+        </p:spPr>
+        <p:style>
+          <a:lnRef idx="1">
+            <a:schemeClr val="accent1"/>
+          </a:lnRef>
+          <a:fillRef idx="3">
+            <a:schemeClr val="accent1"/>
+          </a:fillRef>
+          <a:effectRef idx="2">
+            <a:schemeClr val="accent1"/>
+          </a:effectRef>
+          <a:fontRef idx="minor">
+            <a:schemeClr val="lt1"/>
+          </a:fontRef>
+        </p:style>
+        <p:txBody>
+          <a:bodyPr rtlCol="0" anchor="ctr"/>
+          <a:lstStyle/>
+          <a:p>
+            <a:pPr algn="ctr"/>
+          </a:p>
+        </p:txBody>
+      </p:sp>
+      <p:pic>
+        <p:nvPicPr>
+          <p:cNvPr id="10" name="Picture 9" descr="qr_github.png"/>
+          <p:cNvPicPr>
+            <a:picLocks noChangeAspect="1"/>
+          </p:cNvPicPr>
+          <p:nvPr/>
+        </p:nvPicPr>
+        <p:blipFill>
+          <a:blip r:embed="rId2"/>
+          <a:stretch>
+            <a:fillRect/>
+          </a:stretch>
+        </p:blipFill>
+        <p:spPr>
+          <a:xfrm>
+            <a:off x="8823960" y="1828800"/>
+            <a:ext cx="2834640" cy="2834640"/>
+          </a:xfrm>
+          <a:prstGeom prst="rect">
+            <a:avLst/>
+          </a:prstGeom>
+        </p:spPr>
+      </p:pic>
+      <p:sp>
+        <p:nvSpPr>
+          <p:cNvPr id="11" name="TextBox 10">
+            <a:hlinkClick r:id="rId3"/>
+          </p:cNvPr>
+          <p:cNvSpPr txBox="1"/>
+          <p:nvPr/>
+        </p:nvSpPr>
+        <p:spPr>
+          <a:xfrm>
+            <a:off x="822960" y="4343400"/>
+            <a:ext cx="7680960" cy="548640"/>
+          </a:xfrm>
+          <a:prstGeom prst="rect">
+            <a:avLst/>
+          </a:prstGeom>
+          <a:noFill/>
+        </p:spPr>
+        <p:txBody>
+          <a:bodyPr wrap="square" anchor="t" lIns="0" rIns="0" tIns="0" bIns="0">
+            <a:spAutoFit/>
+          </a:bodyPr>
+          <a:lstStyle/>
+          <a:p>
+            <a:pPr algn="l">
+              <a:lnSpc>
+                <a:spcPct val="105000"/>
+              </a:lnSpc>
+            </a:pPr>
+            <a:r>
+              <a:rPr sz="2800" b="1" u="sng">
+                <a:solidFill>
+                  <a:srgbClr val="FFFFFF"/>
+                </a:solidFill>
+                <a:latin typeface="Helvetica Neue"/>
+                <a:cs typeface="Apple SD Gothic Neo"/>
+                <a:ea typeface="Apple SD Gothic Neo"/>
+              </a:rPr>
+              <a:t>github.com/khabibro/ADVS</a:t>
+            </a:r>
+          </a:p>
+        </p:txBody>
+      </p:sp>
+      <p:sp>
+        <p:nvSpPr>
+          <p:cNvPr id="12" name="TextBox 11"/>
           <p:cNvSpPr txBox="1"/>
           <p:nvPr/>
         </p:nvSpPr>

</xml_diff>